<commit_message>
Add speaker notes to Matematikk presentation
Co-Authored-By: Claude Opus 5.5 <noreply@anthropic.com>
Claude-Session: https://claude.ai/code/session_01HpTJujtrqcBLVroyLjJfQk
</commit_message>
<xml_diff>
--- a/Matematikk.pptx
+++ b/Matematikk.pptx
@@ -508,7 +508,7 @@
           <a:p>
             <a:r>
               <a:rPr lang="en-US" dirty="0"/>
-              <a:t/>
+              <a:t>Hei! Jeg skal snakke om matte på tivoli.</a:t>
             </a:r>
             <a:endParaRPr lang="en-US" dirty="0"/>
           </a:p>
@@ -596,7 +596,7 @@
           <a:p>
             <a:r>
               <a:rPr lang="en-US" dirty="0"/>
-              <a:t/>
+              <a:t>Det kommer tivoli til byen. Eieren har sagt at jeg får gratis inngang hvis jeg kan vise at det er mye matte på et tivolibesøk.</a:t>
             </a:r>
             <a:endParaRPr lang="en-US" dirty="0"/>
           </a:p>
@@ -684,7 +684,7 @@
           <a:p>
             <a:r>
               <a:rPr lang="en-US" dirty="0"/>
-              <a:t/>
+              <a:t>Det kommer tivoli til byen. Eieren har sagt at jeg får gratis inngang hvis jeg kan vise at det er mye matte på et tivolibesøk. Mange tenker at tivoli bare er gøy, men det er faktisk matte overalt. Jeg skal snakke om prisene, lykkehjulet og pariserhjulet.</a:t>
             </a:r>
             <a:endParaRPr lang="en-US" dirty="0"/>
           </a:p>
@@ -772,7 +772,13 @@
           <a:p>
             <a:r>
               <a:rPr lang="en-US" dirty="0"/>
-              <a:t/>
+              <a:t>Lykkehjulet har 12 felt. Det er 4 farger: rød, blå, gul og grønn. Hver farge har 3 felt, og alle feltene er like store.
+For å finne sannsynligheten tar jeg antall gunstige utfall og deler på antall mulige utfall.
+Hvis jeg vil ha rød, er det 3 felt som er røde. Det er de gunstige utfallene.
+Hjulet har 12 felt til sammen. Det er de mulige utfallene.
+Da blir sjansen for rød 3 av 12. Det er det samme som 1 av 4, altså 25 prosent.
+Alle fargene har 3 felt, så det er like stor sjanse for alle fargene.
+Sjansen for å ikke få rød er 9 av 12. Det er det samme som 3 av 4, altså 75 prosent.</a:t>
             </a:r>
             <a:endParaRPr lang="en-US" dirty="0"/>
           </a:p>
@@ -860,7 +866,9 @@
           <a:p>
             <a:r>
               <a:rPr lang="en-US" dirty="0"/>
-              <a:t/>
+              <a:t>Pariserhjulet er rundt som en sirkel som går rundt
+Radius er fra midten av hjulet og ut til kanten. Det er halvparten av 50, altså 25 meter.
+En runde er 3,14 ganger 50 så det blir 157 meter På en runde.</a:t>
             </a:r>
             <a:endParaRPr lang="en-US" dirty="0"/>
           </a:p>
@@ -948,7 +956,12 @@
           <a:p>
             <a:r>
               <a:rPr lang="en-US" dirty="0"/>
-              <a:t/>
+              <a:t>Arket sier ikke når tivoliet stenger, så jeg har valgt det selv. På hverdager stenger det klokka 21, og i helgen stenger det klokka 22.
+På hverdager åpner det klokka 17. Fra 17 til 21 er det 4 timer.
+På lørdag åpner det klokka 12. Fra 12 til 22 er det 10 timer.
+På søndag åpner det klokka 13. Fra 13 til 22 er det 9 timer.
+Det er 5 hverdager, så jeg ganger 4 timer med 5. Det blir 20 timer. Så legger jeg til lørdag og søndag. 20 pluss 10 pluss 9 blir 39 timer.
+Tivoliet er åpent 39 timer i uka.</a:t>
             </a:r>
             <a:endParaRPr lang="en-US" dirty="0"/>
           </a:p>
@@ -1036,7 +1049,12 @@
           <a:p>
             <a:r>
               <a:rPr lang="en-US" dirty="0"/>
-              <a:t/>
+              <a:t>En vanlig billett koster 45 kroner.
+Et rabatthefte har 7 billetter og koster 260 kroner.
+Hvis jeg deler 260 på 7, blir det ca. 37 kroner per billett. Det er billigere enn en vanlig billett.
+Kjøper jeg 7 vanlige billetter, koster det 7 ganger 45, som er 315 kroner.
+Med heftet sparer jeg 315 minus 260, altså 55 kroner.
+Heftet lønner seg hvis man skal ta 6 turer eller mer.</a:t>
             </a:r>
             <a:endParaRPr lang="en-US" dirty="0"/>
           </a:p>
@@ -2520,7 +2538,7 @@
       </p:sp>
       <p:sp>
         <p:nvSpPr>
-          <p:cNvPr id="23" name="Text 0"/>
+          <p:cNvPr id="24" name="Text 0"/>
           <p:cNvSpPr/>
           <p:nvPr>
             <p:ph idx="100" type="title" hasCustomPrompt="1"/>

</xml_diff>